<commit_message>
data-eng 5-1 덱 5(w5d1s0 신설)·묶음
</commit_message>
<xml_diff>
--- a/data-eng/decks/w5d1s1.pptx
+++ b/data-eng/decks/w5d1s1.pptx
@@ -3100,7 +3100,7 @@
       <p:grpSpPr/>
       <p:sp>
         <p:nvSpPr>
-          <p:cNvPr id="2" name="Oval 1"/>
+          <p:cNvPr id="2" name="deckgen:decor"/>
           <p:cNvSpPr/>
           <p:nvPr/>
         </p:nvSpPr>
@@ -3130,7 +3130,7 @@
       </p:sp>
       <p:sp>
         <p:nvSpPr>
-          <p:cNvPr id="3" name="Oval 2"/>
+          <p:cNvPr id="3" name="deckgen:decor"/>
           <p:cNvSpPr/>
           <p:nvPr/>
         </p:nvSpPr>
@@ -3160,7 +3160,7 @@
       </p:sp>
       <p:sp>
         <p:nvSpPr>
-          <p:cNvPr id="4" name="Oval 3"/>
+          <p:cNvPr id="4" name="deckgen:decor"/>
           <p:cNvSpPr/>
           <p:nvPr/>
         </p:nvSpPr>
@@ -3190,7 +3190,7 @@
       </p:sp>
       <p:sp>
         <p:nvSpPr>
-          <p:cNvPr id="5" name="Rectangle 4"/>
+          <p:cNvPr id="5" name="deckgen:decor"/>
           <p:cNvSpPr/>
           <p:nvPr/>
         </p:nvSpPr>
@@ -3220,7 +3220,7 @@
       </p:sp>
       <p:sp>
         <p:nvSpPr>
-          <p:cNvPr id="6" name="Oval 5"/>
+          <p:cNvPr id="6" name="deckgen:decor"/>
           <p:cNvSpPr/>
           <p:nvPr/>
         </p:nvSpPr>
@@ -3250,7 +3250,7 @@
       </p:sp>
       <p:sp>
         <p:nvSpPr>
-          <p:cNvPr id="7" name="Oval 6"/>
+          <p:cNvPr id="7" name="deckgen:decor"/>
           <p:cNvSpPr/>
           <p:nvPr/>
         </p:nvSpPr>
@@ -3280,7 +3280,7 @@
       </p:sp>
       <p:sp>
         <p:nvSpPr>
-          <p:cNvPr id="8" name="Oval 7"/>
+          <p:cNvPr id="8" name="deckgen:decor"/>
           <p:cNvSpPr/>
           <p:nvPr/>
         </p:nvSpPr>
@@ -3310,7 +3310,7 @@
       </p:sp>
       <p:sp>
         <p:nvSpPr>
-          <p:cNvPr id="9" name="Oval 8"/>
+          <p:cNvPr id="9" name="deckgen:decor"/>
           <p:cNvSpPr/>
           <p:nvPr/>
         </p:nvSpPr>
@@ -3340,7 +3340,7 @@
       </p:sp>
       <p:sp>
         <p:nvSpPr>
-          <p:cNvPr id="10" name="Rectangle 9"/>
+          <p:cNvPr id="10" name="deckgen:decor"/>
           <p:cNvSpPr/>
           <p:nvPr/>
         </p:nvSpPr>
@@ -3600,7 +3600,7 @@
       <p:grpSpPr/>
       <p:sp>
         <p:nvSpPr>
-          <p:cNvPr id="2" name="Oval 1"/>
+          <p:cNvPr id="2" name="deckgen:decor"/>
           <p:cNvSpPr/>
           <p:nvPr/>
         </p:nvSpPr>
@@ -3630,7 +3630,7 @@
       </p:sp>
       <p:sp>
         <p:nvSpPr>
-          <p:cNvPr id="3" name="Oval 2"/>
+          <p:cNvPr id="3" name="deckgen:decor"/>
           <p:cNvSpPr/>
           <p:nvPr/>
         </p:nvSpPr>
@@ -3660,7 +3660,7 @@
       </p:sp>
       <p:sp>
         <p:nvSpPr>
-          <p:cNvPr id="4" name="Oval 3"/>
+          <p:cNvPr id="4" name="deckgen:decor"/>
           <p:cNvSpPr/>
           <p:nvPr/>
         </p:nvSpPr>
@@ -4662,7 +4662,7 @@
       <p:grpSpPr/>
       <p:sp>
         <p:nvSpPr>
-          <p:cNvPr id="2" name="Oval 1"/>
+          <p:cNvPr id="2" name="deckgen:decor"/>
           <p:cNvSpPr/>
           <p:nvPr/>
         </p:nvSpPr>
@@ -4692,7 +4692,7 @@
       </p:sp>
       <p:sp>
         <p:nvSpPr>
-          <p:cNvPr id="3" name="Oval 2"/>
+          <p:cNvPr id="3" name="deckgen:decor"/>
           <p:cNvSpPr/>
           <p:nvPr/>
         </p:nvSpPr>
@@ -4827,7 +4827,7 @@
                 <a:ea typeface="Pretendard"/>
                 <a:cs typeface="Pretendard"/>
               </a:rPr>
-              <a:t>다음은 PySpark 첫 실행 실습 (1.5H)</a:t>
+              <a:t>다음은 단일 노드 Spark 기동과 PySpark 첫 실행 (1.5H)</a:t>
             </a:r>
           </a:p>
         </p:txBody>
@@ -4868,7 +4868,7 @@
                 <a:ea typeface="Pretendard"/>
                 <a:cs typeface="Pretendard"/>
               </a:rPr>
-              <a:t>컨테이너로 PySpark 를 띄우고, transformation 만 걸었을 때 Job 이 0 인 것을 UI 로 확인합니다</a:t>
+              <a:t>컨테이너로 PySpark 를 띄우고, 지연 평가를 Spark UI(localhost:4040)로 직접 확인합니다</a:t>
             </a:r>
           </a:p>
         </p:txBody>
@@ -5216,7 +5216,7 @@
                 <a:ea typeface="Pretendard"/>
                 <a:cs typeface="Pretendard"/>
               </a:rPr>
-              <a:t>transformation 뒤 Jobs 탭이 비어 있는지</a:t>
+              <a:t>transformation 뒤 Completed Jobs 가 없는지</a:t>
             </a:r>
           </a:p>
         </p:txBody>
@@ -5332,7 +5332,7 @@
                 <a:ea typeface="Pretendard"/>
                 <a:cs typeface="Pretendard"/>
               </a:rPr>
-              <a:t>count() 뒤 Job 이 생기는지 · explain()</a:t>
+              <a:t>count() 로 Job 둘 · show(5) 로 셋 · explain()</a:t>
             </a:r>
           </a:p>
         </p:txBody>
@@ -5444,7 +5444,7 @@
                 <a:ea typeface="Pretendard"/>
                 <a:cs typeface="Pretendard"/>
               </a:rPr>
-              <a:t>Docker 실행 · 4주차 컨테이너 내려 두기</a:t>
+              <a:t>Docker 실행 · 4주차 컨테이너 멈추기(stop)</a:t>
             </a:r>
           </a:p>
         </p:txBody>
@@ -5469,7 +5469,7 @@
       <p:grpSpPr/>
       <p:sp>
         <p:nvSpPr>
-          <p:cNvPr id="2" name="Oval 1"/>
+          <p:cNvPr id="2" name="deckgen:decor"/>
           <p:cNvSpPr/>
           <p:nvPr/>
         </p:nvSpPr>
@@ -5499,7 +5499,7 @@
       </p:sp>
       <p:sp>
         <p:nvSpPr>
-          <p:cNvPr id="3" name="Oval 2"/>
+          <p:cNvPr id="3" name="deckgen:decor"/>
           <p:cNvSpPr/>
           <p:nvPr/>
         </p:nvSpPr>
@@ -5529,7 +5529,7 @@
       </p:sp>
       <p:sp>
         <p:nvSpPr>
-          <p:cNvPr id="4" name="Oval 3"/>
+          <p:cNvPr id="4" name="deckgen:decor"/>
           <p:cNvSpPr/>
           <p:nvPr/>
         </p:nvSpPr>
@@ -6460,7 +6460,7 @@
       <p:grpSpPr/>
       <p:sp>
         <p:nvSpPr>
-          <p:cNvPr id="2" name="Oval 1"/>
+          <p:cNvPr id="2" name="deckgen:decor"/>
           <p:cNvSpPr/>
           <p:nvPr/>
         </p:nvSpPr>
@@ -6490,7 +6490,7 @@
       </p:sp>
       <p:sp>
         <p:nvSpPr>
-          <p:cNvPr id="3" name="Oval 2"/>
+          <p:cNvPr id="3" name="deckgen:decor"/>
           <p:cNvSpPr/>
           <p:nvPr/>
         </p:nvSpPr>
@@ -6520,7 +6520,7 @@
       </p:sp>
       <p:sp>
         <p:nvSpPr>
-          <p:cNvPr id="4" name="Oval 3"/>
+          <p:cNvPr id="4" name="deckgen:decor"/>
           <p:cNvSpPr/>
           <p:nvPr/>
         </p:nvSpPr>
@@ -7521,7 +7521,7 @@
       <p:grpSpPr/>
       <p:sp>
         <p:nvSpPr>
-          <p:cNvPr id="2" name="Oval 1"/>
+          <p:cNvPr id="2" name="deckgen:decor"/>
           <p:cNvSpPr/>
           <p:nvPr/>
         </p:nvSpPr>
@@ -7551,7 +7551,7 @@
       </p:sp>
       <p:sp>
         <p:nvSpPr>
-          <p:cNvPr id="3" name="Oval 2"/>
+          <p:cNvPr id="3" name="deckgen:decor"/>
           <p:cNvSpPr/>
           <p:nvPr/>
         </p:nvSpPr>
@@ -7581,7 +7581,7 @@
       </p:sp>
       <p:sp>
         <p:nvSpPr>
-          <p:cNvPr id="4" name="Oval 3"/>
+          <p:cNvPr id="4" name="deckgen:decor"/>
           <p:cNvSpPr/>
           <p:nvPr/>
         </p:nvSpPr>
@@ -8909,7 +8909,7 @@
       <p:grpSpPr/>
       <p:sp>
         <p:nvSpPr>
-          <p:cNvPr id="2" name="Oval 1"/>
+          <p:cNvPr id="2" name="deckgen:decor"/>
           <p:cNvSpPr/>
           <p:nvPr/>
         </p:nvSpPr>
@@ -8939,7 +8939,7 @@
       </p:sp>
       <p:sp>
         <p:nvSpPr>
-          <p:cNvPr id="3" name="Oval 2"/>
+          <p:cNvPr id="3" name="deckgen:decor"/>
           <p:cNvSpPr/>
           <p:nvPr/>
         </p:nvSpPr>
@@ -8969,7 +8969,7 @@
       </p:sp>
       <p:sp>
         <p:nvSpPr>
-          <p:cNvPr id="4" name="Oval 3"/>
+          <p:cNvPr id="4" name="deckgen:decor"/>
           <p:cNvSpPr/>
           <p:nvPr/>
         </p:nvSpPr>
@@ -10007,7 +10007,7 @@
       <p:grpSpPr/>
       <p:sp>
         <p:nvSpPr>
-          <p:cNvPr id="2" name="Oval 1"/>
+          <p:cNvPr id="2" name="deckgen:decor"/>
           <p:cNvSpPr/>
           <p:nvPr/>
         </p:nvSpPr>
@@ -10037,7 +10037,7 @@
       </p:sp>
       <p:sp>
         <p:nvSpPr>
-          <p:cNvPr id="3" name="Oval 2"/>
+          <p:cNvPr id="3" name="deckgen:decor"/>
           <p:cNvSpPr/>
           <p:nvPr/>
         </p:nvSpPr>
@@ -10067,7 +10067,7 @@
       </p:sp>
       <p:sp>
         <p:nvSpPr>
-          <p:cNvPr id="4" name="Oval 3"/>
+          <p:cNvPr id="4" name="deckgen:decor"/>
           <p:cNvSpPr/>
           <p:nvPr/>
         </p:nvSpPr>
@@ -11718,7 +11718,7 @@
       <p:grpSpPr/>
       <p:sp>
         <p:nvSpPr>
-          <p:cNvPr id="2" name="Oval 1"/>
+          <p:cNvPr id="2" name="deckgen:decor"/>
           <p:cNvSpPr/>
           <p:nvPr/>
         </p:nvSpPr>
@@ -11748,7 +11748,7 @@
       </p:sp>
       <p:sp>
         <p:nvSpPr>
-          <p:cNvPr id="3" name="Oval 2"/>
+          <p:cNvPr id="3" name="deckgen:decor"/>
           <p:cNvSpPr/>
           <p:nvPr/>
         </p:nvSpPr>
@@ -11778,7 +11778,7 @@
       </p:sp>
       <p:sp>
         <p:nvSpPr>
-          <p:cNvPr id="4" name="Oval 3"/>
+          <p:cNvPr id="4" name="deckgen:decor"/>
           <p:cNvSpPr/>
           <p:nvPr/>
         </p:nvSpPr>
@@ -12921,7 +12921,7 @@
       <p:grpSpPr/>
       <p:sp>
         <p:nvSpPr>
-          <p:cNvPr id="2" name="Oval 1"/>
+          <p:cNvPr id="2" name="deckgen:decor"/>
           <p:cNvSpPr/>
           <p:nvPr/>
         </p:nvSpPr>
@@ -12951,7 +12951,7 @@
       </p:sp>
       <p:sp>
         <p:nvSpPr>
-          <p:cNvPr id="3" name="Oval 2"/>
+          <p:cNvPr id="3" name="deckgen:decor"/>
           <p:cNvSpPr/>
           <p:nvPr/>
         </p:nvSpPr>
@@ -12981,7 +12981,7 @@
       </p:sp>
       <p:sp>
         <p:nvSpPr>
-          <p:cNvPr id="4" name="Oval 3"/>
+          <p:cNvPr id="4" name="deckgen:decor"/>
           <p:cNvSpPr/>
           <p:nvPr/>
         </p:nvSpPr>
@@ -13844,7 +13844,7 @@
       <p:grpSpPr/>
       <p:sp>
         <p:nvSpPr>
-          <p:cNvPr id="2" name="Oval 1"/>
+          <p:cNvPr id="2" name="deckgen:decor"/>
           <p:cNvSpPr/>
           <p:nvPr/>
         </p:nvSpPr>
@@ -13874,7 +13874,7 @@
       </p:sp>
       <p:sp>
         <p:nvSpPr>
-          <p:cNvPr id="3" name="Oval 2"/>
+          <p:cNvPr id="3" name="deckgen:decor"/>
           <p:cNvSpPr/>
           <p:nvPr/>
         </p:nvSpPr>
@@ -13904,7 +13904,7 @@
       </p:sp>
       <p:sp>
         <p:nvSpPr>
-          <p:cNvPr id="4" name="Oval 3"/>
+          <p:cNvPr id="4" name="deckgen:decor"/>
           <p:cNvSpPr/>
           <p:nvPr/>
         </p:nvSpPr>
@@ -14185,7 +14185,7 @@
                 <a:ea typeface="Pretendard"/>
                 <a:cs typeface="Pretendard"/>
               </a:rPr>
-              <a:t>count() 를 두 번</a:t>
+              <a:t>count · show ·</a:t>
             </a:r>
           </a:p>
           <a:p>
@@ -14203,7 +14203,7 @@
                 <a:ea typeface="Pretendard"/>
                 <a:cs typeface="Pretendard"/>
               </a:rPr>
-              <a:t>부르면 Job 두 개</a:t>
+              <a:t>write 를 부른다</a:t>
             </a:r>
           </a:p>
         </p:txBody>
@@ -14379,7 +14379,7 @@
                 <a:ea typeface="Pretendard"/>
                 <a:cs typeface="Pretendard"/>
               </a:rPr>
-              <a:t>action 하나당</a:t>
+              <a:t>action 을 불러야 생긴다</a:t>
             </a:r>
           </a:p>
           <a:p>
@@ -14397,7 +14397,7 @@
                 <a:ea typeface="Pretendard"/>
                 <a:cs typeface="Pretendard"/>
               </a:rPr>
-              <a:t>하나</a:t>
+              <a:t>— 하나가 여럿도</a:t>
             </a:r>
           </a:p>
         </p:txBody>
@@ -14860,7 +14860,7 @@
                 <a:ea typeface="Pretendard"/>
                 <a:cs typeface="Pretendard"/>
               </a:rPr>
-              <a:t>Stage 가 여럿이면 셔플이 있었다는 뜻 · 파티션이 4개면 Task 4개가 병렬로 돈다</a:t>
+              <a:t>실습에서 count() 한 번에 Job 둘, show(5) 한 번에 셋 · Stage 가 여럿이면 셔플이 있었다 · 파티션 4개면 Task 4개</a:t>
             </a:r>
           </a:p>
         </p:txBody>

</xml_diff>